<commit_message>
LiveFX Business: Gründer Tuncay Sancak, Investor Relations Gönül Demet, Stand Oktober 2026, Pre-Seed 500.000 € mit Mittelverwendung (DE/TR/EN)
- Businesspläne, Pitch-Decks, Vision, Quellen, LinkedIn, Landingpage, README angepasst
- SOM im Pitch an den Businessplan angeglichen, tools/README dreisprachig

Co-Authored-By: Claude Opus 5.5 <noreply@anthropic.com>
Claude-Session: https://claude.ai/code/session_01STcnjfrFEd99DGQ7JM2gQ3
</commit_message>
<xml_diff>
--- a/live-fx/business/LiveFX_Pitch.pptx
+++ b/live-fx/business/LiveFX_Pitch.pptx
@@ -123,7 +123,7 @@
   <p:extLst>
     <p:ext uri="{521415D9-36F7-43E2-AB2F-B90AF26B5E84}">
       <p14:sectionLst xmlns:p14="http://schemas.microsoft.com/office/powerpoint/2010/main">
-        <p14:section name="Heute: LiveFX 2.0" id="{8ffd8f69-e8b6-99de-6714-8a43f1c69431}">
+        <p14:section name="Heute: LiveFX 2.0" id="{115b8b9e-bf86-2021-5767-a3c9bdfc864b}">
           <p14:sldIdLst>
             <p14:sldId id="256"/>
             <p14:sldId id="257"/>
@@ -138,7 +138,7 @@
             <p14:sldId id="266"/>
           </p14:sldIdLst>
         </p14:section>
-        <p14:section name="Vision 2027–2029" id="{c3cec9d8-d335-2fd6-baaf-142a4a0aa5e4}">
+        <p14:section name="Vision 2027–2029" id="{00220776-bcbe-4b51-2862-a09e2039e5bc}">
           <p14:sldIdLst>
             <p14:sldId id="267"/>
             <p14:sldId id="268"/>
@@ -146,7 +146,7 @@
             <p14:sldId id="270"/>
           </p14:sldIdLst>
         </p14:section>
-        <p14:section name="Team und Ask" id="{500c9499-6bd4-e492-6478-cf2d6c76bbcd}">
+        <p14:section name="Team und Ask" id="{c70f0e0e-fd10-f567-8485-fd3b814d12b8}">
           <p14:sldIdLst>
             <p14:sldId id="271"/>
             <p14:sldId id="272"/>
@@ -1556,7 +1556,7 @@
           <a:p>
             <a:r>
               <a:rPr lang="en-US" dirty="0"/>
-              <a:t>Die Gründerin ist Nutzerin, Content-Lieferantin und Produktverantwortliche in einer Person – das ist der Grund, warum das Produkt in Dialekten, Hochkant und Türkçe funktioniert. Und als Kinderbuchautorin bringt sie den ersten Verlags- und Bildungsfall selbst mit. Mit dem Seed kommen zwei Hires; für WortBild holen wir fachliche Prüfung über einen Edtech-Beirat.</a:t>
+              <a:t>Der Gründer ist Nutzer, Content-Lieferant und Produktverantwortlicher in einer Person – das ist der Grund, warum das Produkt in Dialekten, Hochkant und Türkçe funktioniert. Und als Kinderbuchautor bringt er den ersten Verlags- und Bildungsfall selbst mit. Gönül Demet verantwortet Investor Relations und ist Ansprechpartnerin für die Pre-Seed-Runde. Mit dem Pre-Seed (500.000 €) kommen zwei Hires; für WortBild holen wir fachliche Prüfung über einen Edtech-Beirat.</a:t>
             </a:r>
             <a:endParaRPr lang="en-US" dirty="0"/>
           </a:p>
@@ -1644,7 +1644,7 @@
           <a:p>
             <a:r>
               <a:rPr lang="en-US" dirty="0"/>
-              <a:t>Konkret enden: Was wir brauchen, ist ein Ansprechpartner im Live-Team und ein 8-Wochen-Pilot mit 20 Creatorn. Wir liefern Overlay, Pakete, Support und die Messung (Watchtime, Gifts, Clips aus Lives). Neu: Für WortBild und Erzählfilm suchen wir einen zweiten Pilot mit Bildungsträgern, Sprachlern-Plattformen oder Verlagen – der erste Verlagsfall ist die eigene Kinderbuchreihe. Das Deck gibt es auch auf Türkisch und Englisch.</a:t>
+              <a:t>Konkret enden: Was wir brauchen, ist ein Ansprechpartner im Live-Team und ein 8-Wochen-Pilot mit 20 Creatorn. Wir liefern Overlay, Pakete, Support und die Messung (Watchtime, Gifts, Clips aus Lives). Neu: Für WortBild und Erzählfilm suchen wir einen zweiten Pilot mit Bildungsträgern, Sprachlern-Plattformen oder Verlagen – der erste Verlagsfall ist die eigene Kinderbuchreihe. Zur Runde: 500.000 € Pre-Seed für LiveFX und alle Projekte, 24 Monate. Mittelverwendung als Vorschlag: Team 250 T€, Vision-Linien 100 T€ (zuerst WortBild/Sprachenlernen und Story-Engine), Go-to-Market 75 T€, Recht/Marke/Datenschutz 50 T€, Reserve 25 T€. Ohne jeden Umsatz reicht das rund 22 Monate; das konservative Szenario ist über drei Jahre gedeckt (Businessplan 11.6). Ansprechpartnerin für Investoren: Gönül Demet. Das Deck gibt es auch auf Türkisch und Englisch.</a:t>
             </a:r>
             <a:endParaRPr lang="en-US" dirty="0"/>
           </a:p>
@@ -2172,7 +2172,7 @@
           <a:p>
             <a:r>
               <a:rPr lang="en-US" dirty="0"/>
-              <a:t>Ehrlich sagen: TAM ist Sekundärquelle mit großer Spanne; SAM und SOM sind unsere Schätzung, keine Studie. Der Punkt ist nicht die genaue Zahl, sondern: Schon ein kleiner Anteil zahlender Live-Creator trägt ein Team – und der eigentliche Hebel ist die Plattform-Integration, nicht das Abo. Unten neu: Die Vision öffnet angrenzende Märkte – KI-Video 3,67 Mrd. USD [Quelle 23], Sprachlern-Apps 1,54 Mrd. USD [Quelle 33], Videoschnitt 2,68 Mrd. USD [Quelle 51], Hörbuch DE 374 Mio. € [Quelle 19]. Die rechnen wir nicht in den SOM ein.</a:t>
+              <a:t>Ehrlich sagen: TAM ist Sekundärquelle mit großer Spanne; SAM und SOM sind unsere Schätzung, keine Studie. Der Punkt ist nicht die genaue Zahl, sondern: Schon ein kleiner Anteil zahlender Live-Creator trägt ein Team – und der eigentliche Hebel ist die Plattform-Integration, nicht das Abo. Unten neu: Die Vision öffnet angrenzende Märkte – KI-Video 3,67 Mrd. USD [Quelle 23], Sprachlern-Apps 1,54 Mrd. USD [Quelle 33], Videoschnitt 2,68 Mrd. USD [Quelle 51], Hörbuch DE 374 Mio. € [Quelle 19]. Die rechnen wir nicht in den SOM ein. Der SOM entspricht dem Businessplan (Kapitel 6): 5.000–15.000 zahlende Nutzer im Jahr 3; das Basis-Szenario rechnet mit Ø 7.500 Pro-Nutzern.</a:t>
             </a:r>
             <a:endParaRPr lang="en-US" dirty="0"/>
           </a:p>
@@ -3131,7 +3131,7 @@
                 <a:ea typeface="Arial" pitchFamily="34" charset="-122"/>
                 <a:cs typeface="Arial" pitchFamily="34" charset="-120"/>
               </a:rPr>
-              <a:t>[Name]</a:t>
+              <a:t>Tuncay Sancak</a:t>
             </a:r>
             <a:pPr indent="0" marL="0">
               <a:buNone/>
@@ -3145,7 +3145,7 @@
                 <a:ea typeface="Arial" pitchFamily="34" charset="-122"/>
                 <a:cs typeface="Arial" pitchFamily="34" charset="-120"/>
               </a:rPr>
-              <a:t>  ·  Gründerin, Autorin &amp; Live-Streamerin</a:t>
+              <a:t>  ·  Gründer &amp; Erfinder, Geschäftsführer</a:t>
             </a:r>
             <a:endParaRPr lang="en-US" sz="1300" dirty="0"/>
           </a:p>
@@ -3162,7 +3162,7 @@
                 <a:ea typeface="Arial" pitchFamily="34" charset="-122"/>
                 <a:cs typeface="Arial" pitchFamily="34" charset="-120"/>
               </a:rPr>
-              <a:t>[Datum]  ·  [E-Mail]</a:t>
+              <a:t>Investor Relations: Gönül Demet  ·  [E-Mail]  ·  Oktober 2026  ·  Vertraulich</a:t>
             </a:r>
             <a:endParaRPr lang="en-US" sz="1300" dirty="0"/>
           </a:p>
@@ -3288,8 +3288,8 @@
         </p:nvSpPr>
         <p:spPr>
           <a:xfrm>
-            <a:off x="9357055" y="6473952"/>
-            <a:ext cx="2286000" cy="228600"/>
+            <a:off x="7071055" y="6473952"/>
+            <a:ext cx="4572000" cy="228600"/>
           </a:xfrm>
           <a:prstGeom prst="rect">
             <a:avLst/>
@@ -3313,7 +3313,7 @@
                 <a:ea typeface="Arial" pitchFamily="34" charset="-122"/>
                 <a:cs typeface="Arial" pitchFamily="34" charset="-120"/>
               </a:rPr>
-              <a:t>LiveFX  ·  10</a:t>
+              <a:t>Vertraulich · Oktober 2026  ·  LiveFX  ·  10</a:t>
             </a:r>
             <a:endParaRPr lang="en-US" sz="900" dirty="0"/>
           </a:p>
@@ -4472,8 +4472,8 @@
         </p:nvSpPr>
         <p:spPr>
           <a:xfrm>
-            <a:off x="9357055" y="6473952"/>
-            <a:ext cx="2286000" cy="228600"/>
+            <a:off x="7071055" y="6473952"/>
+            <a:ext cx="4572000" cy="228600"/>
           </a:xfrm>
           <a:prstGeom prst="rect">
             <a:avLst/>
@@ -4497,7 +4497,7 @@
                 <a:ea typeface="Arial" pitchFamily="34" charset="-122"/>
                 <a:cs typeface="Arial" pitchFamily="34" charset="-120"/>
               </a:rPr>
-              <a:t>LiveFX  ·  11</a:t>
+              <a:t>Vertraulich · Oktober 2026  ·  LiveFX  ·  11</a:t>
             </a:r>
             <a:endParaRPr lang="en-US" sz="900" dirty="0"/>
           </a:p>
@@ -5453,8 +5453,8 @@
         </p:nvSpPr>
         <p:spPr>
           <a:xfrm>
-            <a:off x="9357055" y="6473952"/>
-            <a:ext cx="2286000" cy="228600"/>
+            <a:off x="7071055" y="6473952"/>
+            <a:ext cx="4572000" cy="228600"/>
           </a:xfrm>
           <a:prstGeom prst="rect">
             <a:avLst/>
@@ -5478,7 +5478,7 @@
                 <a:ea typeface="Arial" pitchFamily="34" charset="-122"/>
                 <a:cs typeface="Arial" pitchFamily="34" charset="-120"/>
               </a:rPr>
-              <a:t>LiveFX  ·  12</a:t>
+              <a:t>Vertraulich · Oktober 2026  ·  LiveFX  ·  12</a:t>
             </a:r>
             <a:endParaRPr lang="en-US" sz="900" dirty="0"/>
           </a:p>
@@ -6846,7 +6846,7 @@
                 <a:ea typeface="Arial" pitchFamily="34" charset="-122"/>
                 <a:cs typeface="Arial" pitchFamily="34" charset="-120"/>
               </a:rPr>
-              <a:t>Aus Stimme wird in unter einer Sekunde Meme, Sound oder Szene – in den eigenen Streams der Gründerin im Einsatz.</a:t>
+              <a:t>Aus Stimme wird in unter einer Sekunde Meme, Sound oder Szene – in den eigenen Streams des Gründers im Einsatz.</a:t>
             </a:r>
             <a:endParaRPr lang="en-US" sz="1200" dirty="0"/>
           </a:p>
@@ -7188,8 +7188,8 @@
         </p:nvSpPr>
         <p:spPr>
           <a:xfrm>
-            <a:off x="9357055" y="6473952"/>
-            <a:ext cx="2286000" cy="228600"/>
+            <a:off x="7071055" y="6473952"/>
+            <a:ext cx="4572000" cy="228600"/>
           </a:xfrm>
           <a:prstGeom prst="rect">
             <a:avLst/>
@@ -7213,7 +7213,7 @@
                 <a:ea typeface="Arial" pitchFamily="34" charset="-122"/>
                 <a:cs typeface="Arial" pitchFamily="34" charset="-120"/>
               </a:rPr>
-              <a:t>LiveFX  ·  13</a:t>
+              <a:t>Vertraulich · Oktober 2026  ·  LiveFX  ·  13</a:t>
             </a:r>
             <a:endParaRPr lang="en-US" sz="900" dirty="0"/>
           </a:p>
@@ -10527,8 +10527,8 @@
         </p:nvSpPr>
         <p:spPr>
           <a:xfrm>
-            <a:off x="9357055" y="6473952"/>
-            <a:ext cx="2286000" cy="228600"/>
+            <a:off x="7071055" y="6473952"/>
+            <a:ext cx="4572000" cy="228600"/>
           </a:xfrm>
           <a:prstGeom prst="rect">
             <a:avLst/>
@@ -10552,7 +10552,7 @@
                 <a:ea typeface="Arial" pitchFamily="34" charset="-122"/>
                 <a:cs typeface="Arial" pitchFamily="34" charset="-120"/>
               </a:rPr>
-              <a:t>LiveFX  ·  14</a:t>
+              <a:t>Vertraulich · Oktober 2026  ·  LiveFX  ·  14</a:t>
             </a:r>
             <a:endParaRPr lang="en-US" sz="900" dirty="0"/>
           </a:p>
@@ -11995,8 +11995,8 @@
         </p:nvSpPr>
         <p:spPr>
           <a:xfrm>
-            <a:off x="9357055" y="6473952"/>
-            <a:ext cx="2286000" cy="228600"/>
+            <a:off x="7071055" y="6473952"/>
+            <a:ext cx="4572000" cy="228600"/>
           </a:xfrm>
           <a:prstGeom prst="rect">
             <a:avLst/>
@@ -12020,7 +12020,7 @@
                 <a:ea typeface="Arial" pitchFamily="34" charset="-122"/>
                 <a:cs typeface="Arial" pitchFamily="34" charset="-120"/>
               </a:rPr>
-              <a:t>LiveFX  ·  15</a:t>
+              <a:t>Vertraulich · Oktober 2026  ·  LiveFX  ·  15</a:t>
             </a:r>
             <a:endParaRPr lang="en-US" sz="900" dirty="0"/>
           </a:p>
@@ -14734,7 +14734,7 @@
                 <a:ea typeface="Arial" pitchFamily="34" charset="-122"/>
                 <a:cs typeface="Arial" pitchFamily="34" charset="-120"/>
               </a:rPr>
-              <a:t>NUTZERIN, AUTORIN, GRÜNDERIN</a:t>
+              <a:t>GRÜNDER, ERFINDER, NUTZER</a:t>
             </a:r>
             <a:endParaRPr lang="en-US" sz="1000" dirty="0"/>
           </a:p>
@@ -14789,8 +14789,8 @@
         </p:nvSpPr>
         <p:spPr>
           <a:xfrm>
-            <a:off x="9357055" y="6473952"/>
-            <a:ext cx="2286000" cy="228600"/>
+            <a:off x="7071055" y="6473952"/>
+            <a:ext cx="4572000" cy="228600"/>
           </a:xfrm>
           <a:prstGeom prst="rect">
             <a:avLst/>
@@ -14814,7 +14814,7 @@
                 <a:ea typeface="Arial" pitchFamily="34" charset="-122"/>
                 <a:cs typeface="Arial" pitchFamily="34" charset="-120"/>
               </a:rPr>
-              <a:t>LiveFX  ·  16</a:t>
+              <a:t>Vertraulich · Oktober 2026  ·  LiveFX  ·  16</a:t>
             </a:r>
             <a:endParaRPr lang="en-US" sz="900" dirty="0"/>
           </a:p>
@@ -14829,11 +14829,11 @@
         <p:spPr>
           <a:xfrm>
             <a:off x="548640" y="1371600"/>
-            <a:ext cx="5120640" cy="4526280"/>
+            <a:ext cx="5120640" cy="3246120"/>
           </a:xfrm>
           <a:prstGeom prst="roundRect">
             <a:avLst>
-              <a:gd name="adj" fmla="val 2424"/>
+              <a:gd name="adj" fmla="val 3380"/>
             </a:avLst>
           </a:prstGeom>
           <a:solidFill>
@@ -14899,7 +14899,7 @@
               <a:buNone/>
             </a:pPr>
             <a:r>
-              <a:rPr lang="en-US" sz="1200" b="1" dirty="0">
+              <a:rPr lang="en-US" sz="2000" b="1" dirty="0">
                 <a:solidFill>
                   <a:srgbClr val="FFFFFF"/>
                 </a:solidFill>
@@ -14907,9 +14907,9 @@
                 <a:ea typeface="Arial" pitchFamily="34" charset="-122"/>
                 <a:cs typeface="Arial" pitchFamily="34" charset="-120"/>
               </a:rPr>
-              <a:t>[Foto]</a:t>
-            </a:r>
-            <a:endParaRPr lang="en-US" sz="1200" dirty="0"/>
+              <a:t>TS</a:t>
+            </a:r>
+            <a:endParaRPr lang="en-US" sz="2000" dirty="0"/>
           </a:p>
         </p:txBody>
       </p:sp>
@@ -14948,7 +14948,7 @@
                 <a:ea typeface="Arial" pitchFamily="34" charset="-122"/>
                 <a:cs typeface="Arial" pitchFamily="34" charset="-120"/>
               </a:rPr>
-              <a:t>[Name]</a:t>
+              <a:t>Tuncay Sancak</a:t>
             </a:r>
             <a:endParaRPr lang="en-US" sz="2200" dirty="0"/>
           </a:p>
@@ -14989,7 +14989,7 @@
                 <a:ea typeface="Arial" pitchFamily="34" charset="-122"/>
                 <a:cs typeface="Arial" pitchFamily="34" charset="-120"/>
               </a:rPr>
-              <a:t>Gründerin · deutsch-türkische Autorin &amp; Live-Streamerin</a:t>
+              <a:t>Gründer &amp; Erfinder · Geschäftsführer · deutsch-türkischer Autor &amp; Live-Streamer</a:t>
             </a:r>
             <a:endParaRPr lang="en-US" sz="1200" dirty="0"/>
           </a:p>
@@ -15003,8 +15003,8 @@
         </p:nvSpPr>
         <p:spPr>
           <a:xfrm>
-            <a:off x="914400" y="3200400"/>
-            <a:ext cx="4480560" cy="2560320"/>
+            <a:off x="914400" y="3108960"/>
+            <a:ext cx="4480560" cy="1417320"/>
           </a:xfrm>
           <a:prstGeom prst="rect">
             <a:avLst/>
@@ -15020,7 +15020,7 @@
           <a:p>
             <a:pPr marL="203200" indent="-203200">
               <a:spcAft>
-                <a:spcPts val="600"/>
+                <a:spcPts val="400"/>
               </a:spcAft>
               <a:buSzPct val="100000"/>
               <a:buChar char="•"/>
@@ -15041,7 +15041,7 @@
           <a:p>
             <a:pPr marL="203200" indent="-203200">
               <a:spcAft>
-                <a:spcPts val="600"/>
+                <a:spcPts val="400"/>
               </a:spcAft>
               <a:buSzPct val="100000"/>
               <a:buChar char="•"/>
@@ -15062,7 +15062,7 @@
           <a:p>
             <a:pPr marL="203200" indent="-203200">
               <a:spcAft>
-                <a:spcPts val="600"/>
+                <a:spcPts val="400"/>
               </a:spcAft>
               <a:buSzPct val="100000"/>
               <a:buChar char="•"/>
@@ -15083,7 +15083,7 @@
           <a:p>
             <a:pPr marL="203200" indent="-203200">
               <a:spcAft>
-                <a:spcPts val="600"/>
+                <a:spcPts val="400"/>
               </a:spcAft>
               <a:buSzPct val="100000"/>
               <a:buChar char="•"/>
@@ -15106,6 +15106,222 @@
       <p:sp>
         <p:nvSpPr>
           <p:cNvPr id="12" name="Shape 9"/>
+          <p:cNvSpPr/>
+          <p:nvPr/>
+        </p:nvSpPr>
+        <p:spPr>
+          <a:xfrm>
+            <a:off x="548640" y="4754880"/>
+            <a:ext cx="5120640" cy="1143000"/>
+          </a:xfrm>
+          <a:prstGeom prst="roundRect">
+            <a:avLst>
+              <a:gd name="adj" fmla="val 9600"/>
+            </a:avLst>
+          </a:prstGeom>
+          <a:solidFill>
+            <a:srgbClr val="1F2330"/>
+          </a:solidFill>
+          <a:ln w="12700">
+            <a:solidFill>
+              <a:srgbClr val="1F2330"/>
+            </a:solidFill>
+            <a:prstDash val="solid"/>
+          </a:ln>
+        </p:spPr>
+      </p:sp>
+      <p:sp>
+        <p:nvSpPr>
+          <p:cNvPr id="13" name="Shape 10"/>
+          <p:cNvSpPr/>
+          <p:nvPr/>
+        </p:nvSpPr>
+        <p:spPr>
+          <a:xfrm>
+            <a:off x="914400" y="4956048"/>
+            <a:ext cx="731520" cy="731520"/>
+          </a:xfrm>
+          <a:prstGeom prst="ellipse">
+            <a:avLst/>
+          </a:prstGeom>
+          <a:solidFill>
+            <a:srgbClr val="181B23"/>
+          </a:solidFill>
+          <a:ln w="19050">
+            <a:solidFill>
+              <a:srgbClr val="FFD166"/>
+            </a:solidFill>
+            <a:prstDash val="solid"/>
+          </a:ln>
+        </p:spPr>
+      </p:sp>
+      <p:sp>
+        <p:nvSpPr>
+          <p:cNvPr id="14" name="Text 11"/>
+          <p:cNvSpPr txBox="1"/>
+          <p:nvPr/>
+        </p:nvSpPr>
+        <p:spPr>
+          <a:xfrm>
+            <a:off x="914400" y="4956048"/>
+            <a:ext cx="731520" cy="731520"/>
+          </a:xfrm>
+          <a:prstGeom prst="rect">
+            <a:avLst/>
+          </a:prstGeom>
+          <a:noFill/>
+          <a:ln/>
+        </p:spPr>
+        <p:txBody>
+          <a:bodyPr wrap="square" lIns="0" tIns="0" rIns="0" bIns="0" rtlCol="0" anchor="ctr">
+            <a:normAutofit/>
+          </a:bodyPr>
+          <a:lstStyle/>
+          <a:p>
+            <a:pPr algn="ctr" indent="0" marL="0">
+              <a:buNone/>
+            </a:pPr>
+            <a:r>
+              <a:rPr lang="en-US" sz="1500" b="1" dirty="0">
+                <a:solidFill>
+                  <a:srgbClr val="FFD166"/>
+                </a:solidFill>
+                <a:latin typeface="Arial" pitchFamily="34" charset="0"/>
+                <a:ea typeface="Arial" pitchFamily="34" charset="-122"/>
+                <a:cs typeface="Arial" pitchFamily="34" charset="-120"/>
+              </a:rPr>
+              <a:t>GD</a:t>
+            </a:r>
+            <a:endParaRPr lang="en-US" sz="1500" dirty="0"/>
+          </a:p>
+        </p:txBody>
+      </p:sp>
+      <p:sp>
+        <p:nvSpPr>
+          <p:cNvPr id="15" name="Text 12"/>
+          <p:cNvSpPr txBox="1"/>
+          <p:nvPr/>
+        </p:nvSpPr>
+        <p:spPr>
+          <a:xfrm>
+            <a:off x="1874520" y="4882896"/>
+            <a:ext cx="3611880" cy="347472"/>
+          </a:xfrm>
+          <a:prstGeom prst="rect">
+            <a:avLst/>
+          </a:prstGeom>
+          <a:noFill/>
+          <a:ln/>
+        </p:spPr>
+        <p:txBody>
+          <a:bodyPr wrap="square" lIns="0" tIns="0" rIns="0" bIns="0" rtlCol="0" anchor="t">
+            <a:normAutofit/>
+          </a:bodyPr>
+          <a:lstStyle/>
+          <a:p>
+            <a:pPr indent="0" marL="0">
+              <a:buNone/>
+            </a:pPr>
+            <a:r>
+              <a:rPr lang="en-US" sz="1700" b="1" dirty="0">
+                <a:solidFill>
+                  <a:srgbClr val="FFFFFF"/>
+                </a:solidFill>
+                <a:latin typeface="Arial" pitchFamily="34" charset="0"/>
+                <a:ea typeface="Arial" pitchFamily="34" charset="-122"/>
+                <a:cs typeface="Arial" pitchFamily="34" charset="-120"/>
+              </a:rPr>
+              <a:t>Gönül Demet</a:t>
+            </a:r>
+            <a:endParaRPr lang="en-US" sz="1700" dirty="0"/>
+          </a:p>
+        </p:txBody>
+      </p:sp>
+      <p:sp>
+        <p:nvSpPr>
+          <p:cNvPr id="16" name="Text 13"/>
+          <p:cNvSpPr txBox="1"/>
+          <p:nvPr/>
+        </p:nvSpPr>
+        <p:spPr>
+          <a:xfrm>
+            <a:off x="1874520" y="5230368"/>
+            <a:ext cx="3611880" cy="256032"/>
+          </a:xfrm>
+          <a:prstGeom prst="rect">
+            <a:avLst/>
+          </a:prstGeom>
+          <a:noFill/>
+          <a:ln/>
+        </p:spPr>
+        <p:txBody>
+          <a:bodyPr wrap="square" lIns="0" tIns="0" rIns="0" bIns="0" rtlCol="0" anchor="t">
+            <a:normAutofit/>
+          </a:bodyPr>
+          <a:lstStyle/>
+          <a:p>
+            <a:pPr indent="0" marL="0">
+              <a:buNone/>
+            </a:pPr>
+            <a:r>
+              <a:rPr lang="en-US" sz="1150" b="1" dirty="0">
+                <a:solidFill>
+                  <a:srgbClr val="FFD166"/>
+                </a:solidFill>
+                <a:latin typeface="Arial" pitchFamily="34" charset="0"/>
+                <a:ea typeface="Arial" pitchFamily="34" charset="-122"/>
+                <a:cs typeface="Arial" pitchFamily="34" charset="-120"/>
+              </a:rPr>
+              <a:t>Investor Relations</a:t>
+            </a:r>
+            <a:endParaRPr lang="en-US" sz="1150" dirty="0"/>
+          </a:p>
+        </p:txBody>
+      </p:sp>
+      <p:sp>
+        <p:nvSpPr>
+          <p:cNvPr id="17" name="Text 14"/>
+          <p:cNvSpPr txBox="1"/>
+          <p:nvPr/>
+        </p:nvSpPr>
+        <p:spPr>
+          <a:xfrm>
+            <a:off x="1874520" y="5504688"/>
+            <a:ext cx="3611880" cy="329184"/>
+          </a:xfrm>
+          <a:prstGeom prst="rect">
+            <a:avLst/>
+          </a:prstGeom>
+          <a:noFill/>
+          <a:ln/>
+        </p:spPr>
+        <p:txBody>
+          <a:bodyPr wrap="square" lIns="0" tIns="0" rIns="0" bIns="0" rtlCol="0" anchor="t">
+            <a:normAutofit/>
+          </a:bodyPr>
+          <a:lstStyle/>
+          <a:p>
+            <a:pPr indent="0" marL="0">
+              <a:buNone/>
+            </a:pPr>
+            <a:r>
+              <a:rPr lang="en-US" sz="1100" dirty="0">
+                <a:solidFill>
+                  <a:srgbClr val="9AA3B5"/>
+                </a:solidFill>
+                <a:latin typeface="Arial" pitchFamily="34" charset="0"/>
+                <a:ea typeface="Arial" pitchFamily="34" charset="-122"/>
+                <a:cs typeface="Arial" pitchFamily="34" charset="-120"/>
+              </a:rPr>
+              <a:t>Ansprechpartnerin für Investoren und die Pre-Seed-Runde</a:t>
+            </a:r>
+            <a:endParaRPr lang="en-US" sz="1100" dirty="0"/>
+          </a:p>
+        </p:txBody>
+      </p:sp>
+      <p:sp>
+        <p:nvSpPr>
+          <p:cNvPr id="18" name="Shape 15"/>
           <p:cNvSpPr/>
           <p:nvPr/>
         </p:nvSpPr>
@@ -15132,7 +15348,7 @@
       </p:sp>
       <p:sp>
         <p:nvSpPr>
-          <p:cNvPr id="13" name="Shape 10"/>
+          <p:cNvPr id="19" name="Shape 16"/>
           <p:cNvSpPr/>
           <p:nvPr/>
         </p:nvSpPr>
@@ -15157,7 +15373,7 @@
       </p:sp>
       <p:sp>
         <p:nvSpPr>
-          <p:cNvPr id="14" name="Text 11"/>
+          <p:cNvPr id="20" name="Text 17"/>
           <p:cNvSpPr txBox="1"/>
           <p:nvPr/>
         </p:nvSpPr>
@@ -15196,7 +15412,7 @@
       </p:sp>
       <p:sp>
         <p:nvSpPr>
-          <p:cNvPr id="15" name="Text 12"/>
+          <p:cNvPr id="21" name="Text 18"/>
           <p:cNvSpPr txBox="1"/>
           <p:nvPr/>
         </p:nvSpPr>
@@ -15237,7 +15453,7 @@
       </p:sp>
       <p:sp>
         <p:nvSpPr>
-          <p:cNvPr id="16" name="Text 13"/>
+          <p:cNvPr id="22" name="Text 19"/>
           <p:cNvSpPr txBox="1"/>
           <p:nvPr/>
         </p:nvSpPr>
@@ -15278,7 +15494,7 @@
       </p:sp>
       <p:sp>
         <p:nvSpPr>
-          <p:cNvPr id="17" name="Shape 14"/>
+          <p:cNvPr id="23" name="Shape 20"/>
           <p:cNvSpPr/>
           <p:nvPr/>
         </p:nvSpPr>
@@ -15305,7 +15521,7 @@
       </p:sp>
       <p:sp>
         <p:nvSpPr>
-          <p:cNvPr id="18" name="Shape 15"/>
+          <p:cNvPr id="24" name="Shape 21"/>
           <p:cNvSpPr/>
           <p:nvPr/>
         </p:nvSpPr>
@@ -15330,7 +15546,7 @@
       </p:sp>
       <p:sp>
         <p:nvSpPr>
-          <p:cNvPr id="19" name="Text 16"/>
+          <p:cNvPr id="25" name="Text 22"/>
           <p:cNvSpPr txBox="1"/>
           <p:nvPr/>
         </p:nvSpPr>
@@ -15369,7 +15585,7 @@
       </p:sp>
       <p:sp>
         <p:nvSpPr>
-          <p:cNvPr id="20" name="Text 17"/>
+          <p:cNvPr id="26" name="Text 23"/>
           <p:cNvSpPr txBox="1"/>
           <p:nvPr/>
         </p:nvSpPr>
@@ -15410,7 +15626,7 @@
       </p:sp>
       <p:sp>
         <p:nvSpPr>
-          <p:cNvPr id="21" name="Text 18"/>
+          <p:cNvPr id="27" name="Text 24"/>
           <p:cNvSpPr txBox="1"/>
           <p:nvPr/>
         </p:nvSpPr>
@@ -15451,7 +15667,7 @@
       </p:sp>
       <p:sp>
         <p:nvSpPr>
-          <p:cNvPr id="22" name="Shape 19"/>
+          <p:cNvPr id="28" name="Shape 25"/>
           <p:cNvSpPr/>
           <p:nvPr/>
         </p:nvSpPr>
@@ -15478,7 +15694,7 @@
       </p:sp>
       <p:sp>
         <p:nvSpPr>
-          <p:cNvPr id="23" name="Shape 20"/>
+          <p:cNvPr id="29" name="Shape 26"/>
           <p:cNvSpPr/>
           <p:nvPr/>
         </p:nvSpPr>
@@ -15503,7 +15719,7 @@
       </p:sp>
       <p:sp>
         <p:nvSpPr>
-          <p:cNvPr id="24" name="Text 21"/>
+          <p:cNvPr id="30" name="Text 27"/>
           <p:cNvSpPr txBox="1"/>
           <p:nvPr/>
         </p:nvSpPr>
@@ -15542,7 +15758,7 @@
       </p:sp>
       <p:sp>
         <p:nvSpPr>
-          <p:cNvPr id="25" name="Text 22"/>
+          <p:cNvPr id="31" name="Text 28"/>
           <p:cNvSpPr txBox="1"/>
           <p:nvPr/>
         </p:nvSpPr>
@@ -15583,7 +15799,7 @@
       </p:sp>
       <p:sp>
         <p:nvSpPr>
-          <p:cNvPr id="26" name="Text 23"/>
+          <p:cNvPr id="32" name="Text 29"/>
           <p:cNvSpPr txBox="1"/>
           <p:nvPr/>
         </p:nvSpPr>
@@ -15616,7 +15832,7 @@
                 <a:ea typeface="Arial" pitchFamily="34" charset="-122"/>
                 <a:cs typeface="Arial" pitchFamily="34" charset="-120"/>
               </a:rPr>
-              <a:t>[Name] · [Name] · Edtech/Didaktik: [Name]</a:t>
+              <a:t>Gesucht: Creator-Management TR · Ex-Produktverantwortung „Live“ einer Plattform · Edtech/Didaktik</a:t>
             </a:r>
             <a:endParaRPr lang="en-US" sz="1200" dirty="0"/>
           </a:p>
@@ -15770,12 +15986,12 @@
         </p:nvSpPr>
         <p:spPr>
           <a:xfrm>
-            <a:off x="548640" y="1828800"/>
-            <a:ext cx="2670734" cy="3246120"/>
+            <a:off x="548640" y="1783080"/>
+            <a:ext cx="2670734" cy="2103120"/>
           </a:xfrm>
           <a:prstGeom prst="roundRect">
             <a:avLst>
-              <a:gd name="adj" fmla="val 4109"/>
+              <a:gd name="adj" fmla="val 5217"/>
             </a:avLst>
           </a:prstGeom>
           <a:solidFill>
@@ -15797,8 +16013,8 @@
         </p:nvSpPr>
         <p:spPr>
           <a:xfrm>
-            <a:off x="777240" y="1993392"/>
-            <a:ext cx="2213534" cy="685800"/>
+            <a:off x="777240" y="1929384"/>
+            <a:ext cx="2213534" cy="457200"/>
           </a:xfrm>
           <a:prstGeom prst="rect">
             <a:avLst/>
@@ -15816,7 +16032,7 @@
               <a:buNone/>
             </a:pPr>
             <a:r>
-              <a:rPr lang="en-US" sz="1800" b="1" dirty="0">
+              <a:rPr lang="en-US" sz="1600" b="1" dirty="0">
                 <a:solidFill>
                   <a:srgbClr val="FF2D75"/>
                 </a:solidFill>
@@ -15826,7 +16042,7 @@
               </a:rPr>
               <a:t>Pilot Plattform</a:t>
             </a:r>
-            <a:endParaRPr lang="en-US" sz="1800" dirty="0"/>
+            <a:endParaRPr lang="en-US" sz="1600" dirty="0"/>
           </a:p>
         </p:txBody>
       </p:sp>
@@ -15838,8 +16054,8 @@
         </p:nvSpPr>
         <p:spPr>
           <a:xfrm>
-            <a:off x="777240" y="2724912"/>
-            <a:ext cx="2213534" cy="2286000"/>
+            <a:off x="777240" y="2423160"/>
+            <a:ext cx="2213534" cy="1371600"/>
           </a:xfrm>
           <a:prstGeom prst="rect">
             <a:avLst/>
@@ -15857,7 +16073,7 @@
               <a:buNone/>
             </a:pPr>
             <a:r>
-              <a:rPr lang="en-US" sz="1300" dirty="0">
+              <a:rPr lang="en-US" sz="1250" dirty="0">
                 <a:solidFill>
                   <a:srgbClr val="FFFFFF"/>
                 </a:solidFill>
@@ -15867,7 +16083,7 @@
               </a:rPr>
               <a:t>LiveFX als Feature in TikTok LIVE Studio, Instagram Live Producer oder YouTube Live. Browser-Quelle läuft heute. 8 Wochen, 20 Creator, gemessene Watchtime, Gifts und Clips.</a:t>
             </a:r>
-            <a:endParaRPr lang="en-US" sz="1300" dirty="0"/>
+            <a:endParaRPr lang="en-US" sz="1250" dirty="0"/>
           </a:p>
         </p:txBody>
       </p:sp>
@@ -15879,121 +16095,12 @@
         </p:nvSpPr>
         <p:spPr>
           <a:xfrm>
-            <a:off x="3356534" y="1828800"/>
-            <a:ext cx="2670734" cy="3246120"/>
+            <a:off x="3356534" y="1783080"/>
+            <a:ext cx="2670734" cy="2103120"/>
           </a:xfrm>
           <a:prstGeom prst="roundRect">
             <a:avLst>
-              <a:gd name="adj" fmla="val 4109"/>
-            </a:avLst>
-          </a:prstGeom>
-          <a:solidFill>
-            <a:srgbClr val="181B23"/>
-          </a:solidFill>
-          <a:ln w="15875">
-            <a:solidFill>
-              <a:srgbClr val="FFD166"/>
-            </a:solidFill>
-            <a:prstDash val="solid"/>
-          </a:ln>
-        </p:spPr>
-      </p:sp>
-      <p:sp>
-        <p:nvSpPr>
-          <p:cNvPr id="9" name="Text 6"/>
-          <p:cNvSpPr txBox="1"/>
-          <p:nvPr/>
-        </p:nvSpPr>
-        <p:spPr>
-          <a:xfrm>
-            <a:off x="3585134" y="1993392"/>
-            <a:ext cx="2213534" cy="685800"/>
-          </a:xfrm>
-          <a:prstGeom prst="rect">
-            <a:avLst/>
-          </a:prstGeom>
-          <a:noFill/>
-          <a:ln/>
-        </p:spPr>
-        <p:txBody>
-          <a:bodyPr wrap="square" lIns="0" tIns="0" rIns="0" bIns="0" rtlCol="0" anchor="t">
-            <a:normAutofit/>
-          </a:bodyPr>
-          <a:lstStyle/>
-          <a:p>
-            <a:pPr indent="0" marL="0">
-              <a:buNone/>
-            </a:pPr>
-            <a:r>
-              <a:rPr lang="en-US" sz="1800" b="1" dirty="0">
-                <a:solidFill>
-                  <a:srgbClr val="FFD166"/>
-                </a:solidFill>
-                <a:latin typeface="Arial" pitchFamily="34" charset="0"/>
-                <a:ea typeface="Arial" pitchFamily="34" charset="-122"/>
-                <a:cs typeface="Arial" pitchFamily="34" charset="-120"/>
-              </a:rPr>
-              <a:t>Pilot Bildung &amp; Sprachen</a:t>
-            </a:r>
-            <a:endParaRPr lang="en-US" sz="1800" dirty="0"/>
-          </a:p>
-        </p:txBody>
-      </p:sp>
-      <p:sp>
-        <p:nvSpPr>
-          <p:cNvPr id="10" name="Text 7"/>
-          <p:cNvSpPr txBox="1"/>
-          <p:nvPr/>
-        </p:nvSpPr>
-        <p:spPr>
-          <a:xfrm>
-            <a:off x="3585134" y="2724912"/>
-            <a:ext cx="2213534" cy="2286000"/>
-          </a:xfrm>
-          <a:prstGeom prst="rect">
-            <a:avLst/>
-          </a:prstGeom>
-          <a:noFill/>
-          <a:ln/>
-        </p:spPr>
-        <p:txBody>
-          <a:bodyPr wrap="square" lIns="0" tIns="0" rIns="0" bIns="0" rtlCol="0" anchor="t">
-            <a:normAutofit/>
-          </a:bodyPr>
-          <a:lstStyle/>
-          <a:p>
-            <a:pPr indent="0" marL="0">
-              <a:buNone/>
-            </a:pPr>
-            <a:r>
-              <a:rPr lang="en-US" sz="1300" dirty="0">
-                <a:solidFill>
-                  <a:srgbClr val="FFFFFF"/>
-                </a:solidFill>
-                <a:latin typeface="Arial" pitchFamily="34" charset="0"/>
-                <a:ea typeface="Arial" pitchFamily="34" charset="-122"/>
-                <a:cs typeface="Arial" pitchFamily="34" charset="-120"/>
-              </a:rPr>
-              <a:t>Bildungsträger, Integrationskurse, Schulen, Sprachlern-Plattformen und Verlage: WortBild und Erzählfilm in [Zahl] Kursen/Klassen bzw. mit [Zahl] Titeln testen.</a:t>
-            </a:r>
-            <a:endParaRPr lang="en-US" sz="1300" dirty="0"/>
-          </a:p>
-        </p:txBody>
-      </p:sp>
-      <p:sp>
-        <p:nvSpPr>
-          <p:cNvPr id="11" name="Shape 8"/>
-          <p:cNvSpPr/>
-          <p:nvPr/>
-        </p:nvSpPr>
-        <p:spPr>
-          <a:xfrm>
-            <a:off x="6164428" y="1828800"/>
-            <a:ext cx="2670734" cy="3246120"/>
-          </a:xfrm>
-          <a:prstGeom prst="roundRect">
-            <a:avLst>
-              <a:gd name="adj" fmla="val 4109"/>
+              <a:gd name="adj" fmla="val 5217"/>
             </a:avLst>
           </a:prstGeom>
           <a:solidFill>
@@ -16009,14 +16116,14 @@
       </p:sp>
       <p:sp>
         <p:nvSpPr>
-          <p:cNvPr id="12" name="Text 9"/>
-          <p:cNvSpPr txBox="1"/>
-          <p:nvPr/>
-        </p:nvSpPr>
-        <p:spPr>
-          <a:xfrm>
-            <a:off x="6393028" y="1993392"/>
-            <a:ext cx="2213534" cy="685800"/>
+          <p:cNvPr id="9" name="Text 6"/>
+          <p:cNvSpPr txBox="1"/>
+          <p:nvPr/>
+        </p:nvSpPr>
+        <p:spPr>
+          <a:xfrm>
+            <a:off x="3585134" y="1929384"/>
+            <a:ext cx="2213534" cy="457200"/>
           </a:xfrm>
           <a:prstGeom prst="rect">
             <a:avLst/>
@@ -16034,30 +16141,30 @@
               <a:buNone/>
             </a:pPr>
             <a:r>
-              <a:rPr lang="en-US" sz="1800" b="1" dirty="0">
-                <a:solidFill>
-                  <a:srgbClr val="2DFFB5"/>
-                </a:solidFill>
-                <a:latin typeface="Arial" pitchFamily="34" charset="0"/>
-                <a:ea typeface="Arial" pitchFamily="34" charset="-122"/>
-                <a:cs typeface="Arial" pitchFamily="34" charset="-120"/>
-              </a:rPr>
-              <a:t>Partner</a:t>
-            </a:r>
-            <a:endParaRPr lang="en-US" sz="1800" dirty="0"/>
-          </a:p>
-        </p:txBody>
-      </p:sp>
-      <p:sp>
-        <p:nvSpPr>
-          <p:cNvPr id="13" name="Text 10"/>
-          <p:cNvSpPr txBox="1"/>
-          <p:nvPr/>
-        </p:nvSpPr>
-        <p:spPr>
-          <a:xfrm>
-            <a:off x="6393028" y="2724912"/>
-            <a:ext cx="2213534" cy="2286000"/>
+              <a:rPr lang="en-US" sz="1550" b="1" dirty="0">
+                <a:solidFill>
+                  <a:srgbClr val="FFD166"/>
+                </a:solidFill>
+                <a:latin typeface="Arial" pitchFamily="34" charset="0"/>
+                <a:ea typeface="Arial" pitchFamily="34" charset="-122"/>
+                <a:cs typeface="Arial" pitchFamily="34" charset="-120"/>
+              </a:rPr>
+              <a:t>Pilot Bildung &amp; Sprachen</a:t>
+            </a:r>
+            <a:endParaRPr lang="en-US" sz="1550" dirty="0"/>
+          </a:p>
+        </p:txBody>
+      </p:sp>
+      <p:sp>
+        <p:nvSpPr>
+          <p:cNvPr id="10" name="Text 7"/>
+          <p:cNvSpPr txBox="1"/>
+          <p:nvPr/>
+        </p:nvSpPr>
+        <p:spPr>
+          <a:xfrm>
+            <a:off x="3585134" y="2423160"/>
+            <a:ext cx="2213534" cy="1371600"/>
           </a:xfrm>
           <a:prstGeom prst="rect">
             <a:avLst/>
@@ -16075,7 +16182,7 @@
               <a:buNone/>
             </a:pPr>
             <a:r>
-              <a:rPr lang="en-US" sz="1300" dirty="0">
+              <a:rPr lang="en-US" sz="1250" dirty="0">
                 <a:solidFill>
                   <a:srgbClr val="FFFFFF"/>
                 </a:solidFill>
@@ -16083,26 +16190,26 @@
                 <a:ea typeface="Arial" pitchFamily="34" charset="-122"/>
                 <a:cs typeface="Arial" pitchFamily="34" charset="-120"/>
               </a:rPr>
-              <a:t>Streaming-Software (OBS-Plug-in, Streamlabs), Creator-Agenturen TR / DACH, Audio- und ASR-Anbieter, Editor-Anbieter (Studio-SDK).</a:t>
-            </a:r>
-            <a:endParaRPr lang="en-US" sz="1300" dirty="0"/>
-          </a:p>
-        </p:txBody>
-      </p:sp>
-      <p:sp>
-        <p:nvSpPr>
-          <p:cNvPr id="14" name="Shape 11"/>
+              <a:t>Bildungsträger, Integrationskurse, Schulen, Sprachlern-Plattformen und Verlage: WortBild und Erzählfilm in [Zahl] Kursen/Klassen bzw. mit [Zahl] Titeln testen.</a:t>
+            </a:r>
+            <a:endParaRPr lang="en-US" sz="1250" dirty="0"/>
+          </a:p>
+        </p:txBody>
+      </p:sp>
+      <p:sp>
+        <p:nvSpPr>
+          <p:cNvPr id="11" name="Shape 8"/>
           <p:cNvSpPr/>
           <p:nvPr/>
         </p:nvSpPr>
         <p:spPr>
           <a:xfrm>
-            <a:off x="8972321" y="1828800"/>
-            <a:ext cx="2670734" cy="3246120"/>
+            <a:off x="6164428" y="1783080"/>
+            <a:ext cx="2670734" cy="2103120"/>
           </a:xfrm>
           <a:prstGeom prst="roundRect">
             <a:avLst>
-              <a:gd name="adj" fmla="val 4109"/>
+              <a:gd name="adj" fmla="val 5217"/>
             </a:avLst>
           </a:prstGeom>
           <a:solidFill>
@@ -16118,14 +16225,123 @@
       </p:sp>
       <p:sp>
         <p:nvSpPr>
+          <p:cNvPr id="12" name="Text 9"/>
+          <p:cNvSpPr txBox="1"/>
+          <p:nvPr/>
+        </p:nvSpPr>
+        <p:spPr>
+          <a:xfrm>
+            <a:off x="6393028" y="1929384"/>
+            <a:ext cx="2213534" cy="457200"/>
+          </a:xfrm>
+          <a:prstGeom prst="rect">
+            <a:avLst/>
+          </a:prstGeom>
+          <a:noFill/>
+          <a:ln/>
+        </p:spPr>
+        <p:txBody>
+          <a:bodyPr wrap="square" lIns="0" tIns="0" rIns="0" bIns="0" rtlCol="0" anchor="t">
+            <a:normAutofit/>
+          </a:bodyPr>
+          <a:lstStyle/>
+          <a:p>
+            <a:pPr indent="0" marL="0">
+              <a:buNone/>
+            </a:pPr>
+            <a:r>
+              <a:rPr lang="en-US" sz="1600" b="1" dirty="0">
+                <a:solidFill>
+                  <a:srgbClr val="2DFFB5"/>
+                </a:solidFill>
+                <a:latin typeface="Arial" pitchFamily="34" charset="0"/>
+                <a:ea typeface="Arial" pitchFamily="34" charset="-122"/>
+                <a:cs typeface="Arial" pitchFamily="34" charset="-120"/>
+              </a:rPr>
+              <a:t>Partner</a:t>
+            </a:r>
+            <a:endParaRPr lang="en-US" sz="1600" dirty="0"/>
+          </a:p>
+        </p:txBody>
+      </p:sp>
+      <p:sp>
+        <p:nvSpPr>
+          <p:cNvPr id="13" name="Text 10"/>
+          <p:cNvSpPr txBox="1"/>
+          <p:nvPr/>
+        </p:nvSpPr>
+        <p:spPr>
+          <a:xfrm>
+            <a:off x="6393028" y="2423160"/>
+            <a:ext cx="2213534" cy="1371600"/>
+          </a:xfrm>
+          <a:prstGeom prst="rect">
+            <a:avLst/>
+          </a:prstGeom>
+          <a:noFill/>
+          <a:ln/>
+        </p:spPr>
+        <p:txBody>
+          <a:bodyPr wrap="square" lIns="0" tIns="0" rIns="0" bIns="0" rtlCol="0" anchor="t">
+            <a:normAutofit/>
+          </a:bodyPr>
+          <a:lstStyle/>
+          <a:p>
+            <a:pPr indent="0" marL="0">
+              <a:buNone/>
+            </a:pPr>
+            <a:r>
+              <a:rPr lang="en-US" sz="1250" dirty="0">
+                <a:solidFill>
+                  <a:srgbClr val="FFFFFF"/>
+                </a:solidFill>
+                <a:latin typeface="Arial" pitchFamily="34" charset="0"/>
+                <a:ea typeface="Arial" pitchFamily="34" charset="-122"/>
+                <a:cs typeface="Arial" pitchFamily="34" charset="-120"/>
+              </a:rPr>
+              <a:t>Streaming-Software (OBS-Plug-in, Streamlabs), Creator-Agenturen TR / DACH, Audio- und ASR-Anbieter, Editor-Anbieter (Studio-SDK).</a:t>
+            </a:r>
+            <a:endParaRPr lang="en-US" sz="1250" dirty="0"/>
+          </a:p>
+        </p:txBody>
+      </p:sp>
+      <p:sp>
+        <p:nvSpPr>
+          <p:cNvPr id="14" name="Shape 11"/>
+          <p:cNvSpPr/>
+          <p:nvPr/>
+        </p:nvSpPr>
+        <p:spPr>
+          <a:xfrm>
+            <a:off x="8972321" y="1783080"/>
+            <a:ext cx="2670734" cy="2103120"/>
+          </a:xfrm>
+          <a:prstGeom prst="roundRect">
+            <a:avLst>
+              <a:gd name="adj" fmla="val 5217"/>
+            </a:avLst>
+          </a:prstGeom>
+          <a:solidFill>
+            <a:srgbClr val="181B23"/>
+          </a:solidFill>
+          <a:ln w="15875">
+            <a:solidFill>
+              <a:srgbClr val="5AD1FF"/>
+            </a:solidFill>
+            <a:prstDash val="solid"/>
+          </a:ln>
+        </p:spPr>
+      </p:sp>
+      <p:sp>
+        <p:nvSpPr>
           <p:cNvPr id="15" name="Text 12"/>
           <p:cNvSpPr txBox="1"/>
           <p:nvPr/>
         </p:nvSpPr>
         <p:spPr>
           <a:xfrm>
-            <a:off x="9200921" y="1993392"/>
-            <a:ext cx="2213534" cy="685800"/>
+            <a:off x="9200921" y="1929384"/>
+            <a:ext cx="2213534" cy="457200"/>
           </a:xfrm>
           <a:prstGeom prst="rect">
             <a:avLst/>
@@ -16143,7 +16359,7 @@
               <a:buNone/>
             </a:pPr>
             <a:r>
-              <a:rPr lang="en-US" sz="1800" b="1" dirty="0">
+              <a:rPr lang="en-US" sz="1600" b="1" dirty="0">
                 <a:solidFill>
                   <a:srgbClr val="5AD1FF"/>
                 </a:solidFill>
@@ -16151,9 +16367,9 @@
                 <a:ea typeface="Arial" pitchFamily="34" charset="-122"/>
                 <a:cs typeface="Arial" pitchFamily="34" charset="-120"/>
               </a:rPr>
-              <a:t>Gespräch &amp; Seed</a:t>
-            </a:r>
-            <a:endParaRPr lang="en-US" sz="1800" dirty="0"/>
+              <a:t>Pre-Seed: 500.000 €</a:t>
+            </a:r>
+            <a:endParaRPr lang="en-US" sz="1600" dirty="0"/>
           </a:p>
         </p:txBody>
       </p:sp>
@@ -16165,8 +16381,8 @@
         </p:nvSpPr>
         <p:spPr>
           <a:xfrm>
-            <a:off x="9200921" y="2724912"/>
-            <a:ext cx="2213534" cy="2286000"/>
+            <a:off x="9200921" y="2423160"/>
+            <a:ext cx="2213534" cy="1371600"/>
           </a:xfrm>
           <a:prstGeom prst="rect">
             <a:avLst/>
@@ -16184,7 +16400,7 @@
               <a:buNone/>
             </a:pPr>
             <a:r>
-              <a:rPr lang="en-US" sz="1300" dirty="0">
+              <a:rPr lang="en-US" sz="1250" dirty="0">
                 <a:solidFill>
                   <a:srgbClr val="FFFFFF"/>
                 </a:solidFill>
@@ -16192,9 +16408,9 @@
                 <a:ea typeface="Arial" pitchFamily="34" charset="-122"/>
                 <a:cs typeface="Arial" pitchFamily="34" charset="-120"/>
               </a:rPr>
-              <a:t>Übernahme-Gespräch: Technologie + Team. Parallel: Seed [Zahl] € für 18 Monate – 2 Hires, Creator-Programm, Piloten.</a:t>
-            </a:r>
-            <a:endParaRPr lang="en-US" sz="1300" dirty="0"/>
+              <a:t>Für LiveFX 2.0 und die Vision-Linien A–D (zuerst WortBild und Story-Engine), 24 Monate. Parallel offen für Übernahme-Gespräche (Technologie + Team).</a:t>
+            </a:r>
+            <a:endParaRPr lang="en-US" sz="1250" dirty="0"/>
           </a:p>
         </p:txBody>
       </p:sp>
@@ -16206,12 +16422,12 @@
         </p:nvSpPr>
         <p:spPr>
           <a:xfrm>
-            <a:off x="548640" y="5303520"/>
-            <a:ext cx="11094415" cy="713232"/>
+            <a:off x="548640" y="4005072"/>
+            <a:ext cx="11094415" cy="1207008"/>
           </a:xfrm>
           <a:prstGeom prst="roundRect">
             <a:avLst>
-              <a:gd name="adj" fmla="val 15385"/>
+              <a:gd name="adj" fmla="val 9091"/>
             </a:avLst>
           </a:prstGeom>
           <a:solidFill>
@@ -16233,6 +16449,734 @@
         </p:nvSpPr>
         <p:spPr>
           <a:xfrm>
+            <a:off x="822960" y="4087368"/>
+            <a:ext cx="10545775" cy="256032"/>
+          </a:xfrm>
+          <a:prstGeom prst="rect">
+            <a:avLst/>
+          </a:prstGeom>
+          <a:noFill/>
+          <a:ln/>
+        </p:spPr>
+        <p:txBody>
+          <a:bodyPr wrap="square" lIns="0" tIns="0" rIns="0" bIns="0" rtlCol="0" anchor="t">
+            <a:normAutofit/>
+          </a:bodyPr>
+          <a:lstStyle/>
+          <a:p>
+            <a:pPr indent="0" marL="0">
+              <a:buNone/>
+            </a:pPr>
+            <a:r>
+              <a:rPr lang="en-US" sz="1200" b="1" dirty="0">
+                <a:solidFill>
+                  <a:srgbClr val="FFD166"/>
+                </a:solidFill>
+                <a:latin typeface="Arial" pitchFamily="34" charset="0"/>
+                <a:ea typeface="Arial" pitchFamily="34" charset="-122"/>
+                <a:cs typeface="Arial" pitchFamily="34" charset="-120"/>
+              </a:rPr>
+              <a:t>500.000 € Pre-Seed · 24 Monate · Mittelverwendung – Vorschlag – bitte bestätigen</a:t>
+            </a:r>
+            <a:endParaRPr lang="en-US" sz="1200" dirty="0"/>
+          </a:p>
+        </p:txBody>
+      </p:sp>
+      <p:sp>
+        <p:nvSpPr>
+          <p:cNvPr id="19" name="Shape 16"/>
+          <p:cNvSpPr/>
+          <p:nvPr/>
+        </p:nvSpPr>
+        <p:spPr>
+          <a:xfrm>
+            <a:off x="822960" y="4407408"/>
+            <a:ext cx="5245456" cy="219456"/>
+          </a:xfrm>
+          <a:prstGeom prst="rect">
+            <a:avLst/>
+          </a:prstGeom>
+          <a:solidFill>
+            <a:srgbClr val="FF2D75"/>
+          </a:solidFill>
+          <a:ln w="12700">
+            <a:solidFill>
+              <a:srgbClr val="FF2D75"/>
+            </a:solidFill>
+            <a:prstDash val="solid"/>
+          </a:ln>
+        </p:spPr>
+      </p:sp>
+      <p:sp>
+        <p:nvSpPr>
+          <p:cNvPr id="20" name="Shape 17"/>
+          <p:cNvSpPr/>
+          <p:nvPr/>
+        </p:nvSpPr>
+        <p:spPr>
+          <a:xfrm>
+            <a:off x="6095848" y="4407408"/>
+            <a:ext cx="2081723" cy="219456"/>
+          </a:xfrm>
+          <a:prstGeom prst="rect">
+            <a:avLst/>
+          </a:prstGeom>
+          <a:solidFill>
+            <a:srgbClr val="2DFFB5"/>
+          </a:solidFill>
+          <a:ln w="12700">
+            <a:solidFill>
+              <a:srgbClr val="2DFFB5"/>
+            </a:solidFill>
+            <a:prstDash val="solid"/>
+          </a:ln>
+        </p:spPr>
+      </p:sp>
+      <p:sp>
+        <p:nvSpPr>
+          <p:cNvPr id="21" name="Shape 18"/>
+          <p:cNvSpPr/>
+          <p:nvPr/>
+        </p:nvSpPr>
+        <p:spPr>
+          <a:xfrm>
+            <a:off x="8205003" y="4407408"/>
+            <a:ext cx="1554434" cy="219456"/>
+          </a:xfrm>
+          <a:prstGeom prst="rect">
+            <a:avLst/>
+          </a:prstGeom>
+          <a:solidFill>
+            <a:srgbClr val="FFD166"/>
+          </a:solidFill>
+          <a:ln w="12700">
+            <a:solidFill>
+              <a:srgbClr val="FFD166"/>
+            </a:solidFill>
+            <a:prstDash val="solid"/>
+          </a:ln>
+        </p:spPr>
+      </p:sp>
+      <p:sp>
+        <p:nvSpPr>
+          <p:cNvPr id="22" name="Shape 19"/>
+          <p:cNvSpPr/>
+          <p:nvPr/>
+        </p:nvSpPr>
+        <p:spPr>
+          <a:xfrm>
+            <a:off x="9786869" y="4407408"/>
+            <a:ext cx="1027146" cy="219456"/>
+          </a:xfrm>
+          <a:prstGeom prst="rect">
+            <a:avLst/>
+          </a:prstGeom>
+          <a:solidFill>
+            <a:srgbClr val="5AD1FF"/>
+          </a:solidFill>
+          <a:ln w="12700">
+            <a:solidFill>
+              <a:srgbClr val="5AD1FF"/>
+            </a:solidFill>
+            <a:prstDash val="solid"/>
+          </a:ln>
+        </p:spPr>
+      </p:sp>
+      <p:sp>
+        <p:nvSpPr>
+          <p:cNvPr id="23" name="Shape 20"/>
+          <p:cNvSpPr/>
+          <p:nvPr/>
+        </p:nvSpPr>
+        <p:spPr>
+          <a:xfrm>
+            <a:off x="10841446" y="4407408"/>
+            <a:ext cx="499857" cy="219456"/>
+          </a:xfrm>
+          <a:prstGeom prst="rect">
+            <a:avLst/>
+          </a:prstGeom>
+          <a:solidFill>
+            <a:srgbClr val="9AA3B5"/>
+          </a:solidFill>
+          <a:ln w="12700">
+            <a:solidFill>
+              <a:srgbClr val="9AA3B5"/>
+            </a:solidFill>
+            <a:prstDash val="solid"/>
+          </a:ln>
+        </p:spPr>
+      </p:sp>
+      <p:sp>
+        <p:nvSpPr>
+          <p:cNvPr id="24" name="Shape 21"/>
+          <p:cNvSpPr/>
+          <p:nvPr/>
+        </p:nvSpPr>
+        <p:spPr>
+          <a:xfrm>
+            <a:off x="822960" y="4773168"/>
+            <a:ext cx="109728" cy="109728"/>
+          </a:xfrm>
+          <a:prstGeom prst="ellipse">
+            <a:avLst/>
+          </a:prstGeom>
+          <a:solidFill>
+            <a:srgbClr val="FF2D75"/>
+          </a:solidFill>
+          <a:ln w="12700">
+            <a:solidFill>
+              <a:srgbClr val="FF2D75"/>
+            </a:solidFill>
+            <a:prstDash val="solid"/>
+          </a:ln>
+        </p:spPr>
+      </p:sp>
+      <p:sp>
+        <p:nvSpPr>
+          <p:cNvPr id="25" name="Text 22"/>
+          <p:cNvSpPr txBox="1"/>
+          <p:nvPr/>
+        </p:nvSpPr>
+        <p:spPr>
+          <a:xfrm>
+            <a:off x="1005840" y="4709160"/>
+            <a:ext cx="1834835" cy="237744"/>
+          </a:xfrm>
+          <a:prstGeom prst="rect">
+            <a:avLst/>
+          </a:prstGeom>
+          <a:noFill/>
+          <a:ln/>
+        </p:spPr>
+        <p:txBody>
+          <a:bodyPr wrap="square" lIns="0" tIns="0" rIns="0" bIns="0" rtlCol="0" anchor="t">
+            <a:normAutofit/>
+          </a:bodyPr>
+          <a:lstStyle/>
+          <a:p>
+            <a:pPr indent="0" marL="0">
+              <a:buNone/>
+            </a:pPr>
+            <a:r>
+              <a:rPr lang="en-US" sz="1000" b="1" dirty="0">
+                <a:solidFill>
+                  <a:srgbClr val="FFFFFF"/>
+                </a:solidFill>
+                <a:latin typeface="Arial" pitchFamily="34" charset="0"/>
+                <a:ea typeface="Arial" pitchFamily="34" charset="-122"/>
+                <a:cs typeface="Arial" pitchFamily="34" charset="-120"/>
+              </a:rPr>
+              <a:t>Produkt &amp; Engineering</a:t>
+            </a:r>
+            <a:endParaRPr lang="en-US" sz="1000" dirty="0"/>
+          </a:p>
+        </p:txBody>
+      </p:sp>
+      <p:sp>
+        <p:nvSpPr>
+          <p:cNvPr id="26" name="Text 23"/>
+          <p:cNvSpPr txBox="1"/>
+          <p:nvPr/>
+        </p:nvSpPr>
+        <p:spPr>
+          <a:xfrm>
+            <a:off x="1005840" y="4937760"/>
+            <a:ext cx="1834835" cy="219456"/>
+          </a:xfrm>
+          <a:prstGeom prst="rect">
+            <a:avLst/>
+          </a:prstGeom>
+          <a:noFill/>
+          <a:ln/>
+        </p:spPr>
+        <p:txBody>
+          <a:bodyPr wrap="square" lIns="0" tIns="0" rIns="0" bIns="0" rtlCol="0" anchor="t">
+            <a:normAutofit/>
+          </a:bodyPr>
+          <a:lstStyle/>
+          <a:p>
+            <a:pPr indent="0" marL="0">
+              <a:buNone/>
+            </a:pPr>
+            <a:r>
+              <a:rPr lang="en-US" sz="1000" dirty="0">
+                <a:solidFill>
+                  <a:srgbClr val="9AA3B5"/>
+                </a:solidFill>
+                <a:latin typeface="Arial" pitchFamily="34" charset="0"/>
+                <a:ea typeface="Arial" pitchFamily="34" charset="-122"/>
+                <a:cs typeface="Arial" pitchFamily="34" charset="-120"/>
+              </a:rPr>
+              <a:t>250 T€ · 50 %</a:t>
+            </a:r>
+            <a:endParaRPr lang="en-US" sz="1000" dirty="0"/>
+          </a:p>
+        </p:txBody>
+      </p:sp>
+      <p:sp>
+        <p:nvSpPr>
+          <p:cNvPr id="27" name="Shape 24"/>
+          <p:cNvSpPr/>
+          <p:nvPr/>
+        </p:nvSpPr>
+        <p:spPr>
+          <a:xfrm>
+            <a:off x="2932115" y="4773168"/>
+            <a:ext cx="109728" cy="109728"/>
+          </a:xfrm>
+          <a:prstGeom prst="ellipse">
+            <a:avLst/>
+          </a:prstGeom>
+          <a:solidFill>
+            <a:srgbClr val="2DFFB5"/>
+          </a:solidFill>
+          <a:ln w="12700">
+            <a:solidFill>
+              <a:srgbClr val="2DFFB5"/>
+            </a:solidFill>
+            <a:prstDash val="solid"/>
+          </a:ln>
+        </p:spPr>
+      </p:sp>
+      <p:sp>
+        <p:nvSpPr>
+          <p:cNvPr id="28" name="Text 25"/>
+          <p:cNvSpPr txBox="1"/>
+          <p:nvPr/>
+        </p:nvSpPr>
+        <p:spPr>
+          <a:xfrm>
+            <a:off x="3114995" y="4709160"/>
+            <a:ext cx="1834835" cy="237744"/>
+          </a:xfrm>
+          <a:prstGeom prst="rect">
+            <a:avLst/>
+          </a:prstGeom>
+          <a:noFill/>
+          <a:ln/>
+        </p:spPr>
+        <p:txBody>
+          <a:bodyPr wrap="square" lIns="0" tIns="0" rIns="0" bIns="0" rtlCol="0" anchor="t">
+            <a:normAutofit/>
+          </a:bodyPr>
+          <a:lstStyle/>
+          <a:p>
+            <a:pPr indent="0" marL="0">
+              <a:buNone/>
+            </a:pPr>
+            <a:r>
+              <a:rPr lang="en-US" sz="1000" b="1" dirty="0">
+                <a:solidFill>
+                  <a:srgbClr val="FFFFFF"/>
+                </a:solidFill>
+                <a:latin typeface="Arial" pitchFamily="34" charset="0"/>
+                <a:ea typeface="Arial" pitchFamily="34" charset="-122"/>
+                <a:cs typeface="Arial" pitchFamily="34" charset="-120"/>
+              </a:rPr>
+              <a:t>Vision-Linien A–D</a:t>
+            </a:r>
+            <a:endParaRPr lang="en-US" sz="1000" dirty="0"/>
+          </a:p>
+        </p:txBody>
+      </p:sp>
+      <p:sp>
+        <p:nvSpPr>
+          <p:cNvPr id="29" name="Text 26"/>
+          <p:cNvSpPr txBox="1"/>
+          <p:nvPr/>
+        </p:nvSpPr>
+        <p:spPr>
+          <a:xfrm>
+            <a:off x="3114995" y="4937760"/>
+            <a:ext cx="1834835" cy="219456"/>
+          </a:xfrm>
+          <a:prstGeom prst="rect">
+            <a:avLst/>
+          </a:prstGeom>
+          <a:noFill/>
+          <a:ln/>
+        </p:spPr>
+        <p:txBody>
+          <a:bodyPr wrap="square" lIns="0" tIns="0" rIns="0" bIns="0" rtlCol="0" anchor="t">
+            <a:normAutofit/>
+          </a:bodyPr>
+          <a:lstStyle/>
+          <a:p>
+            <a:pPr indent="0" marL="0">
+              <a:buNone/>
+            </a:pPr>
+            <a:r>
+              <a:rPr lang="en-US" sz="1000" dirty="0">
+                <a:solidFill>
+                  <a:srgbClr val="9AA3B5"/>
+                </a:solidFill>
+                <a:latin typeface="Arial" pitchFamily="34" charset="0"/>
+                <a:ea typeface="Arial" pitchFamily="34" charset="-122"/>
+                <a:cs typeface="Arial" pitchFamily="34" charset="-120"/>
+              </a:rPr>
+              <a:t>100 T€ · 20 %</a:t>
+            </a:r>
+            <a:endParaRPr lang="en-US" sz="1000" dirty="0"/>
+          </a:p>
+        </p:txBody>
+      </p:sp>
+      <p:sp>
+        <p:nvSpPr>
+          <p:cNvPr id="30" name="Shape 27"/>
+          <p:cNvSpPr/>
+          <p:nvPr/>
+        </p:nvSpPr>
+        <p:spPr>
+          <a:xfrm>
+            <a:off x="5041270" y="4773168"/>
+            <a:ext cx="109728" cy="109728"/>
+          </a:xfrm>
+          <a:prstGeom prst="ellipse">
+            <a:avLst/>
+          </a:prstGeom>
+          <a:solidFill>
+            <a:srgbClr val="FFD166"/>
+          </a:solidFill>
+          <a:ln w="12700">
+            <a:solidFill>
+              <a:srgbClr val="FFD166"/>
+            </a:solidFill>
+            <a:prstDash val="solid"/>
+          </a:ln>
+        </p:spPr>
+      </p:sp>
+      <p:sp>
+        <p:nvSpPr>
+          <p:cNvPr id="31" name="Text 28"/>
+          <p:cNvSpPr txBox="1"/>
+          <p:nvPr/>
+        </p:nvSpPr>
+        <p:spPr>
+          <a:xfrm>
+            <a:off x="5224150" y="4709160"/>
+            <a:ext cx="1834835" cy="237744"/>
+          </a:xfrm>
+          <a:prstGeom prst="rect">
+            <a:avLst/>
+          </a:prstGeom>
+          <a:noFill/>
+          <a:ln/>
+        </p:spPr>
+        <p:txBody>
+          <a:bodyPr wrap="square" lIns="0" tIns="0" rIns="0" bIns="0" rtlCol="0" anchor="t">
+            <a:normAutofit/>
+          </a:bodyPr>
+          <a:lstStyle/>
+          <a:p>
+            <a:pPr indent="0" marL="0">
+              <a:buNone/>
+            </a:pPr>
+            <a:r>
+              <a:rPr lang="en-US" sz="1000" b="1" dirty="0">
+                <a:solidFill>
+                  <a:srgbClr val="FFFFFF"/>
+                </a:solidFill>
+                <a:latin typeface="Arial" pitchFamily="34" charset="0"/>
+                <a:ea typeface="Arial" pitchFamily="34" charset="-122"/>
+                <a:cs typeface="Arial" pitchFamily="34" charset="-120"/>
+              </a:rPr>
+              <a:t>Go-to-Market &amp; Piloten</a:t>
+            </a:r>
+            <a:endParaRPr lang="en-US" sz="1000" dirty="0"/>
+          </a:p>
+        </p:txBody>
+      </p:sp>
+      <p:sp>
+        <p:nvSpPr>
+          <p:cNvPr id="32" name="Text 29"/>
+          <p:cNvSpPr txBox="1"/>
+          <p:nvPr/>
+        </p:nvSpPr>
+        <p:spPr>
+          <a:xfrm>
+            <a:off x="5224150" y="4937760"/>
+            <a:ext cx="1834835" cy="219456"/>
+          </a:xfrm>
+          <a:prstGeom prst="rect">
+            <a:avLst/>
+          </a:prstGeom>
+          <a:noFill/>
+          <a:ln/>
+        </p:spPr>
+        <p:txBody>
+          <a:bodyPr wrap="square" lIns="0" tIns="0" rIns="0" bIns="0" rtlCol="0" anchor="t">
+            <a:normAutofit/>
+          </a:bodyPr>
+          <a:lstStyle/>
+          <a:p>
+            <a:pPr indent="0" marL="0">
+              <a:buNone/>
+            </a:pPr>
+            <a:r>
+              <a:rPr lang="en-US" sz="1000" dirty="0">
+                <a:solidFill>
+                  <a:srgbClr val="9AA3B5"/>
+                </a:solidFill>
+                <a:latin typeface="Arial" pitchFamily="34" charset="0"/>
+                <a:ea typeface="Arial" pitchFamily="34" charset="-122"/>
+                <a:cs typeface="Arial" pitchFamily="34" charset="-120"/>
+              </a:rPr>
+              <a:t>75 T€ · 15 %</a:t>
+            </a:r>
+            <a:endParaRPr lang="en-US" sz="1000" dirty="0"/>
+          </a:p>
+        </p:txBody>
+      </p:sp>
+      <p:sp>
+        <p:nvSpPr>
+          <p:cNvPr id="33" name="Shape 30"/>
+          <p:cNvSpPr/>
+          <p:nvPr/>
+        </p:nvSpPr>
+        <p:spPr>
+          <a:xfrm>
+            <a:off x="7150425" y="4773168"/>
+            <a:ext cx="109728" cy="109728"/>
+          </a:xfrm>
+          <a:prstGeom prst="ellipse">
+            <a:avLst/>
+          </a:prstGeom>
+          <a:solidFill>
+            <a:srgbClr val="5AD1FF"/>
+          </a:solidFill>
+          <a:ln w="12700">
+            <a:solidFill>
+              <a:srgbClr val="5AD1FF"/>
+            </a:solidFill>
+            <a:prstDash val="solid"/>
+          </a:ln>
+        </p:spPr>
+      </p:sp>
+      <p:sp>
+        <p:nvSpPr>
+          <p:cNvPr id="34" name="Text 31"/>
+          <p:cNvSpPr txBox="1"/>
+          <p:nvPr/>
+        </p:nvSpPr>
+        <p:spPr>
+          <a:xfrm>
+            <a:off x="7333305" y="4709160"/>
+            <a:ext cx="1834835" cy="237744"/>
+          </a:xfrm>
+          <a:prstGeom prst="rect">
+            <a:avLst/>
+          </a:prstGeom>
+          <a:noFill/>
+          <a:ln/>
+        </p:spPr>
+        <p:txBody>
+          <a:bodyPr wrap="square" lIns="0" tIns="0" rIns="0" bIns="0" rtlCol="0" anchor="t">
+            <a:normAutofit/>
+          </a:bodyPr>
+          <a:lstStyle/>
+          <a:p>
+            <a:pPr indent="0" marL="0">
+              <a:buNone/>
+            </a:pPr>
+            <a:r>
+              <a:rPr lang="en-US" sz="1000" b="1" dirty="0">
+                <a:solidFill>
+                  <a:srgbClr val="FFFFFF"/>
+                </a:solidFill>
+                <a:latin typeface="Arial" pitchFamily="34" charset="0"/>
+                <a:ea typeface="Arial" pitchFamily="34" charset="-122"/>
+                <a:cs typeface="Arial" pitchFamily="34" charset="-120"/>
+              </a:rPr>
+              <a:t>Recht, Marke, Datenschutz</a:t>
+            </a:r>
+            <a:endParaRPr lang="en-US" sz="1000" dirty="0"/>
+          </a:p>
+        </p:txBody>
+      </p:sp>
+      <p:sp>
+        <p:nvSpPr>
+          <p:cNvPr id="35" name="Text 32"/>
+          <p:cNvSpPr txBox="1"/>
+          <p:nvPr/>
+        </p:nvSpPr>
+        <p:spPr>
+          <a:xfrm>
+            <a:off x="7333305" y="4937760"/>
+            <a:ext cx="1834835" cy="219456"/>
+          </a:xfrm>
+          <a:prstGeom prst="rect">
+            <a:avLst/>
+          </a:prstGeom>
+          <a:noFill/>
+          <a:ln/>
+        </p:spPr>
+        <p:txBody>
+          <a:bodyPr wrap="square" lIns="0" tIns="0" rIns="0" bIns="0" rtlCol="0" anchor="t">
+            <a:normAutofit/>
+          </a:bodyPr>
+          <a:lstStyle/>
+          <a:p>
+            <a:pPr indent="0" marL="0">
+              <a:buNone/>
+            </a:pPr>
+            <a:r>
+              <a:rPr lang="en-US" sz="1000" dirty="0">
+                <a:solidFill>
+                  <a:srgbClr val="9AA3B5"/>
+                </a:solidFill>
+                <a:latin typeface="Arial" pitchFamily="34" charset="0"/>
+                <a:ea typeface="Arial" pitchFamily="34" charset="-122"/>
+                <a:cs typeface="Arial" pitchFamily="34" charset="-120"/>
+              </a:rPr>
+              <a:t>50 T€ · 10 %</a:t>
+            </a:r>
+            <a:endParaRPr lang="en-US" sz="1000" dirty="0"/>
+          </a:p>
+        </p:txBody>
+      </p:sp>
+      <p:sp>
+        <p:nvSpPr>
+          <p:cNvPr id="36" name="Shape 33"/>
+          <p:cNvSpPr/>
+          <p:nvPr/>
+        </p:nvSpPr>
+        <p:spPr>
+          <a:xfrm>
+            <a:off x="9259580" y="4773168"/>
+            <a:ext cx="109728" cy="109728"/>
+          </a:xfrm>
+          <a:prstGeom prst="ellipse">
+            <a:avLst/>
+          </a:prstGeom>
+          <a:solidFill>
+            <a:srgbClr val="9AA3B5"/>
+          </a:solidFill>
+          <a:ln w="12700">
+            <a:solidFill>
+              <a:srgbClr val="9AA3B5"/>
+            </a:solidFill>
+            <a:prstDash val="solid"/>
+          </a:ln>
+        </p:spPr>
+      </p:sp>
+      <p:sp>
+        <p:nvSpPr>
+          <p:cNvPr id="37" name="Text 34"/>
+          <p:cNvSpPr txBox="1"/>
+          <p:nvPr/>
+        </p:nvSpPr>
+        <p:spPr>
+          <a:xfrm>
+            <a:off x="9442460" y="4709160"/>
+            <a:ext cx="1834835" cy="237744"/>
+          </a:xfrm>
+          <a:prstGeom prst="rect">
+            <a:avLst/>
+          </a:prstGeom>
+          <a:noFill/>
+          <a:ln/>
+        </p:spPr>
+        <p:txBody>
+          <a:bodyPr wrap="square" lIns="0" tIns="0" rIns="0" bIns="0" rtlCol="0" anchor="t">
+            <a:normAutofit/>
+          </a:bodyPr>
+          <a:lstStyle/>
+          <a:p>
+            <a:pPr indent="0" marL="0">
+              <a:buNone/>
+            </a:pPr>
+            <a:r>
+              <a:rPr lang="en-US" sz="1000" b="1" dirty="0">
+                <a:solidFill>
+                  <a:srgbClr val="FFFFFF"/>
+                </a:solidFill>
+                <a:latin typeface="Arial" pitchFamily="34" charset="0"/>
+                <a:ea typeface="Arial" pitchFamily="34" charset="-122"/>
+                <a:cs typeface="Arial" pitchFamily="34" charset="-120"/>
+              </a:rPr>
+              <a:t>Reserve</a:t>
+            </a:r>
+            <a:endParaRPr lang="en-US" sz="1000" dirty="0"/>
+          </a:p>
+        </p:txBody>
+      </p:sp>
+      <p:sp>
+        <p:nvSpPr>
+          <p:cNvPr id="38" name="Text 35"/>
+          <p:cNvSpPr txBox="1"/>
+          <p:nvPr/>
+        </p:nvSpPr>
+        <p:spPr>
+          <a:xfrm>
+            <a:off x="9442460" y="4937760"/>
+            <a:ext cx="1834835" cy="219456"/>
+          </a:xfrm>
+          <a:prstGeom prst="rect">
+            <a:avLst/>
+          </a:prstGeom>
+          <a:noFill/>
+          <a:ln/>
+        </p:spPr>
+        <p:txBody>
+          <a:bodyPr wrap="square" lIns="0" tIns="0" rIns="0" bIns="0" rtlCol="0" anchor="t">
+            <a:normAutofit/>
+          </a:bodyPr>
+          <a:lstStyle/>
+          <a:p>
+            <a:pPr indent="0" marL="0">
+              <a:buNone/>
+            </a:pPr>
+            <a:r>
+              <a:rPr lang="en-US" sz="1000" dirty="0">
+                <a:solidFill>
+                  <a:srgbClr val="9AA3B5"/>
+                </a:solidFill>
+                <a:latin typeface="Arial" pitchFamily="34" charset="0"/>
+                <a:ea typeface="Arial" pitchFamily="34" charset="-122"/>
+                <a:cs typeface="Arial" pitchFamily="34" charset="-120"/>
+              </a:rPr>
+              <a:t>25 T€ · 5 %</a:t>
+            </a:r>
+            <a:endParaRPr lang="en-US" sz="1000" dirty="0"/>
+          </a:p>
+        </p:txBody>
+      </p:sp>
+      <p:sp>
+        <p:nvSpPr>
+          <p:cNvPr id="39" name="Shape 36"/>
+          <p:cNvSpPr/>
+          <p:nvPr/>
+        </p:nvSpPr>
+        <p:spPr>
+          <a:xfrm>
+            <a:off x="548640" y="5303520"/>
+            <a:ext cx="11094415" cy="713232"/>
+          </a:xfrm>
+          <a:prstGeom prst="roundRect">
+            <a:avLst>
+              <a:gd name="adj" fmla="val 15385"/>
+            </a:avLst>
+          </a:prstGeom>
+          <a:solidFill>
+            <a:srgbClr val="1F2330"/>
+          </a:solidFill>
+          <a:ln w="12700">
+            <a:solidFill>
+              <a:srgbClr val="1F2330"/>
+            </a:solidFill>
+            <a:prstDash val="solid"/>
+          </a:ln>
+        </p:spPr>
+      </p:sp>
+      <p:sp>
+        <p:nvSpPr>
+          <p:cNvPr id="40" name="Text 37"/>
+          <p:cNvSpPr txBox="1"/>
+          <p:nvPr/>
+        </p:nvSpPr>
+        <p:spPr>
+          <a:xfrm>
             <a:off x="822960" y="5321808"/>
             <a:ext cx="10545775" cy="676656"/>
           </a:xfrm>
@@ -16260,7 +17204,7 @@
                 <a:ea typeface="Arial" pitchFamily="34" charset="-122"/>
                 <a:cs typeface="Arial" pitchFamily="34" charset="-120"/>
               </a:rPr>
-              <a:t>Kontakt: [E-Mail]   ·   Demo: [Link]   ·   Code &amp; Doku: live-fx/   ·   [Name]</a:t>
+              <a:t>Tuncay Sancak, Gründer &amp; Geschäftsführer   ·   Investor Relations: Gönül Demet   ·   [E-Mail]   ·   Demo: [Link]</a:t>
             </a:r>
             <a:endParaRPr lang="en-US" sz="1500" dirty="0"/>
           </a:p>
@@ -16268,7 +17212,7 @@
       </p:sp>
       <p:sp>
         <p:nvSpPr>
-          <p:cNvPr id="19" name="Text 16"/>
+          <p:cNvPr id="41" name="Text 38"/>
           <p:cNvSpPr txBox="1"/>
           <p:nvPr/>
         </p:nvSpPr>
@@ -16309,14 +17253,14 @@
       </p:sp>
       <p:sp>
         <p:nvSpPr>
-          <p:cNvPr id="20" name="Text 17"/>
-          <p:cNvSpPr txBox="1"/>
-          <p:nvPr/>
-        </p:nvSpPr>
-        <p:spPr>
-          <a:xfrm>
-            <a:off x="9357055" y="6473952"/>
-            <a:ext cx="2286000" cy="228600"/>
+          <p:cNvPr id="42" name="Text 39"/>
+          <p:cNvSpPr txBox="1"/>
+          <p:nvPr/>
+        </p:nvSpPr>
+        <p:spPr>
+          <a:xfrm>
+            <a:off x="7071055" y="6473952"/>
+            <a:ext cx="4572000" cy="228600"/>
           </a:xfrm>
           <a:prstGeom prst="rect">
             <a:avLst/>
@@ -16340,7 +17284,7 @@
                 <a:ea typeface="Arial" pitchFamily="34" charset="-122"/>
                 <a:cs typeface="Arial" pitchFamily="34" charset="-120"/>
               </a:rPr>
-              <a:t>LiveFX  ·  17</a:t>
+              <a:t>Vertraulich · Oktober 2026  ·  LiveFX  ·  17</a:t>
             </a:r>
             <a:endParaRPr lang="en-US" sz="900" dirty="0"/>
           </a:p>
@@ -16466,8 +17410,8 @@
         </p:nvSpPr>
         <p:spPr>
           <a:xfrm>
-            <a:off x="9357055" y="6473952"/>
-            <a:ext cx="2286000" cy="228600"/>
+            <a:off x="7071055" y="6473952"/>
+            <a:ext cx="4572000" cy="228600"/>
           </a:xfrm>
           <a:prstGeom prst="rect">
             <a:avLst/>
@@ -16491,7 +17435,7 @@
                 <a:ea typeface="Arial" pitchFamily="34" charset="-122"/>
                 <a:cs typeface="Arial" pitchFamily="34" charset="-120"/>
               </a:rPr>
-              <a:t>LiveFX  ·  2</a:t>
+              <a:t>Vertraulich · Oktober 2026  ·  LiveFX  ·  2</a:t>
             </a:r>
             <a:endParaRPr lang="en-US" sz="900" dirty="0"/>
           </a:p>
@@ -17160,7 +18104,7 @@
                 <a:ea typeface="Arial" pitchFamily="34" charset="-122"/>
                 <a:cs typeface="Arial" pitchFamily="34" charset="-120"/>
               </a:rPr>
-              <a:t>„Ich sage ‚krass‘ – und nichts passiert, außer dass ich selbst zur Tastatur greife.“  – [Name], aus dem eigenen Stream</a:t>
+              <a:t>„Ich sage ‚krass‘ – und nichts passiert, außer dass ich selbst zur Tastatur greife.“  – Tuncay Sancak, aus dem eigenen Stream</a:t>
             </a:r>
             <a:endParaRPr lang="en-US" sz="1400" dirty="0"/>
           </a:p>
@@ -17286,8 +18230,8 @@
         </p:nvSpPr>
         <p:spPr>
           <a:xfrm>
-            <a:off x="9357055" y="6473952"/>
-            <a:ext cx="2286000" cy="228600"/>
+            <a:off x="7071055" y="6473952"/>
+            <a:ext cx="4572000" cy="228600"/>
           </a:xfrm>
           <a:prstGeom prst="rect">
             <a:avLst/>
@@ -17311,7 +18255,7 @@
                 <a:ea typeface="Arial" pitchFamily="34" charset="-122"/>
                 <a:cs typeface="Arial" pitchFamily="34" charset="-120"/>
               </a:rPr>
-              <a:t>LiveFX  ·  3</a:t>
+              <a:t>Vertraulich · Oktober 2026  ·  LiveFX  ·  3</a:t>
             </a:r>
             <a:endParaRPr lang="en-US" sz="900" dirty="0"/>
           </a:p>
@@ -18924,8 +19868,8 @@
         </p:nvSpPr>
         <p:spPr>
           <a:xfrm>
-            <a:off x="9357055" y="6473952"/>
-            <a:ext cx="2286000" cy="228600"/>
+            <a:off x="7071055" y="6473952"/>
+            <a:ext cx="4572000" cy="228600"/>
           </a:xfrm>
           <a:prstGeom prst="rect">
             <a:avLst/>
@@ -18949,7 +19893,7 @@
                 <a:ea typeface="Arial" pitchFamily="34" charset="-122"/>
                 <a:cs typeface="Arial" pitchFamily="34" charset="-120"/>
               </a:rPr>
-              <a:t>LiveFX  ·  4</a:t>
+              <a:t>Vertraulich · Oktober 2026  ·  LiveFX  ·  4</a:t>
             </a:r>
             <a:endParaRPr lang="en-US" sz="900" dirty="0"/>
           </a:p>
@@ -19338,8 +20282,8 @@
         </p:nvSpPr>
         <p:spPr>
           <a:xfrm>
-            <a:off x="9357055" y="6473952"/>
-            <a:ext cx="2286000" cy="228600"/>
+            <a:off x="7071055" y="6473952"/>
+            <a:ext cx="4572000" cy="228600"/>
           </a:xfrm>
           <a:prstGeom prst="rect">
             <a:avLst/>
@@ -19363,7 +20307,7 @@
                 <a:ea typeface="Arial" pitchFamily="34" charset="-122"/>
                 <a:cs typeface="Arial" pitchFamily="34" charset="-120"/>
               </a:rPr>
-              <a:t>LiveFX  ·  5</a:t>
+              <a:t>Vertraulich · Oktober 2026  ·  LiveFX  ·  5</a:t>
             </a:r>
             <a:endParaRPr lang="en-US" sz="900" dirty="0"/>
           </a:p>
@@ -20673,8 +21617,8 @@
         </p:nvSpPr>
         <p:spPr>
           <a:xfrm>
-            <a:off x="9357055" y="6473952"/>
-            <a:ext cx="2286000" cy="228600"/>
+            <a:off x="7071055" y="6473952"/>
+            <a:ext cx="4572000" cy="228600"/>
           </a:xfrm>
           <a:prstGeom prst="rect">
             <a:avLst/>
@@ -20698,7 +21642,7 @@
                 <a:ea typeface="Arial" pitchFamily="34" charset="-122"/>
                 <a:cs typeface="Arial" pitchFamily="34" charset="-120"/>
               </a:rPr>
-              <a:t>LiveFX  ·  6</a:t>
+              <a:t>Vertraulich · Oktober 2026  ·  LiveFX  ·  6</a:t>
             </a:r>
             <a:endParaRPr lang="en-US" sz="900" dirty="0"/>
           </a:p>
@@ -21438,8 +22382,8 @@
         </p:nvSpPr>
         <p:spPr>
           <a:xfrm>
-            <a:off x="9357055" y="6473952"/>
-            <a:ext cx="2286000" cy="228600"/>
+            <a:off x="7071055" y="6473952"/>
+            <a:ext cx="4572000" cy="228600"/>
           </a:xfrm>
           <a:prstGeom prst="rect">
             <a:avLst/>
@@ -21463,7 +22407,7 @@
                 <a:ea typeface="Arial" pitchFamily="34" charset="-122"/>
                 <a:cs typeface="Arial" pitchFamily="34" charset="-120"/>
               </a:rPr>
-              <a:t>LiveFX  ·  7</a:t>
+              <a:t>Vertraulich · Oktober 2026  ·  LiveFX  ·  7</a:t>
             </a:r>
             <a:endParaRPr lang="en-US" sz="900" dirty="0"/>
           </a:p>
@@ -21929,7 +22873,7 @@
                 <a:ea typeface="Arial" pitchFamily="34" charset="-122"/>
                 <a:cs typeface="Arial" pitchFamily="34" charset="-120"/>
               </a:rPr>
-              <a:t>20–40 T Pro-Abos × 9,99 €/Monat ≈ 2,4–4,8 Mio. € ARR (DACH + Türkei + EN-Nische)</a:t>
+              <a:t>5.000–15.000 zahlende Pro-Nutzer × 9,99 €/Monat ≈ 0,6–1,8 Mio. € ARR (wie Businessplan; DACH + Türkei + EN-Nische)</a:t>
             </a:r>
             <a:endParaRPr lang="en-US" sz="1050" dirty="0"/>
           </a:p>
@@ -22573,8 +23517,8 @@
         </p:nvSpPr>
         <p:spPr>
           <a:xfrm>
-            <a:off x="9357055" y="6473952"/>
-            <a:ext cx="2286000" cy="228600"/>
+            <a:off x="7071055" y="6473952"/>
+            <a:ext cx="4572000" cy="228600"/>
           </a:xfrm>
           <a:prstGeom prst="rect">
             <a:avLst/>
@@ -22598,7 +23542,7 @@
                 <a:ea typeface="Arial" pitchFamily="34" charset="-122"/>
                 <a:cs typeface="Arial" pitchFamily="34" charset="-120"/>
               </a:rPr>
-              <a:t>LiveFX  ·  8</a:t>
+              <a:t>Vertraulich · Oktober 2026  ·  LiveFX  ·  8</a:t>
             </a:r>
             <a:endParaRPr lang="en-US" sz="900" dirty="0"/>
           </a:p>
@@ -23567,8 +24511,8 @@
         </p:nvSpPr>
         <p:spPr>
           <a:xfrm>
-            <a:off x="9357055" y="6473952"/>
-            <a:ext cx="2286000" cy="228600"/>
+            <a:off x="7071055" y="6473952"/>
+            <a:ext cx="4572000" cy="228600"/>
           </a:xfrm>
           <a:prstGeom prst="rect">
             <a:avLst/>
@@ -23592,7 +24536,7 @@
                 <a:ea typeface="Arial" pitchFamily="34" charset="-122"/>
                 <a:cs typeface="Arial" pitchFamily="34" charset="-120"/>
               </a:rPr>
-              <a:t>LiveFX  ·  9</a:t>
+              <a:t>Vertraulich · Oktober 2026  ·  LiveFX  ·  9</a:t>
             </a:r>
             <a:endParaRPr lang="en-US" sz="900" dirty="0"/>
           </a:p>

</xml_diff>

<commit_message>
Investorenunterlagen 250.000 € / 10 %: Vision, Quellen, README, TR-Pitch fertig; Konsistenzprüfung aller Dateien gegen das Finanzmodell
Co-Authored-By: Claude Opus 5.5 <noreply@anthropic.com>
Claude-Session: https://claude.ai/code/session_01STcnjfrFEd99DGQ7JM2gQ3
</commit_message>
<xml_diff>
--- a/live-fx/business/LiveFX_Pitch.pptx
+++ b/live-fx/business/LiveFX_Pitch.pptx
@@ -125,7 +125,7 @@
   <p:extLst>
     <p:ext uri="{521415D9-36F7-43E2-AB2F-B90AF26B5E84}">
       <p14:sectionLst xmlns:p14="http://schemas.microsoft.com/office/powerpoint/2010/main">
-        <p14:section name="Heute: LiveFX 2.1" id="{f1613e5f-53a5-6353-1122-f7dc61b0abbd}">
+        <p14:section name="Heute: LiveFX 2.1" id="{6c83759f-4bf6-04f8-9990-41d100ceda1c}">
           <p14:sldIdLst>
             <p14:sldId id="256"/>
             <p14:sldId id="257"/>
@@ -140,7 +140,7 @@
             <p14:sldId id="266"/>
           </p14:sldIdLst>
         </p14:section>
-        <p14:section name="Vision 2027–2029" id="{7fa908a5-2b7a-2e04-7c8a-963e9d4c976d}">
+        <p14:section name="Vision 2027–2029" id="{d691f47b-67f7-c1e9-31e8-09aeb43193e9}">
           <p14:sldIdLst>
             <p14:sldId id="267"/>
             <p14:sldId id="268"/>
@@ -148,7 +148,7 @@
             <p14:sldId id="270"/>
           </p14:sldIdLst>
         </p14:section>
-        <p14:section name="Team und Ask" id="{f7b1e52c-d0ae-9a81-acc4-95620f33f16c}">
+        <p14:section name="Team und Ask" id="{56375c3a-fcd5-b1e1-534a-f531db1d4e1b}">
           <p14:sldIdLst>
             <p14:sldId id="271"/>
             <p14:sldId id="272"/>
@@ -19255,7 +19255,7 @@
                 <a:ea typeface="Arial" pitchFamily="34" charset="-122"/>
                 <a:cs typeface="Arial" pitchFamily="34" charset="-120"/>
               </a:rPr>
-              <a:t>Pre-Money · 250 T€ für 10,0 % · Post-Money 2,5 Mio. €</a:t>
+              <a:t>Pre-Money · 250 T€ für 10,0 % · Post-Money 2,5 Mio. €</a:t>
             </a:r>
             <a:endParaRPr lang="en-US" sz="1200" dirty="0"/>
           </a:p>
@@ -21592,7 +21592,7 @@
                 <a:ea typeface="Arial" pitchFamily="34" charset="-122"/>
                 <a:cs typeface="Arial" pitchFamily="34" charset="-120"/>
               </a:rPr>
-              <a:t>Für 10 % (Pre-Money 2,25 Mio. €, Post 2,5 Mio. €) oder SAFE mit 2,25 Mio. € Cap. 18 Monate, schlank: Pro-Abo, Mobile-App/PWA, TR → DE/EN-Launch, WortBild.</a:t>
+              <a:t>Für 10 % (Pre-Money 2,25 Mio. €, Post 2,5 Mio. €) oder SAFE mit 2,25 Mio. € Cap. 18 Monate, schlank: Pro-Abo, Mobile-App/PWA, TR → DE/EN-Launch, WortBild.</a:t>
             </a:r>
             <a:endParaRPr lang="en-US" sz="1250" dirty="0"/>
           </a:p>

</xml_diff>